<commit_message>
Refresh the deck, the video script and the team briefing
The PDF and PowerPoint decks now cover the reranker, policy learning, sealed
storage, setup codes, peers, photos, backup, the shift report and the phone
layout, with the current screenshots and test count; the PDF is printed from
docs/deck.html so it can be regenerated without PowerPoint. The video script
and team briefing use the one-click conflict, the cross-platform commands and
the setup-code flow.
</commit_message>
<xml_diff>
--- a/docs/FieldMind-Compilers.pptx
+++ b/docs/FieldMind-Compilers.pptx
@@ -2656,7 +2656,7 @@
                 <a:ea typeface="Calibri" pitchFamily="34" charset="-122"/>
                 <a:cs typeface="Calibri" pitchFamily="34" charset="-120"/>
               </a:rPr>
-              <a:t>Write what you saw. The device shows what it will share before you save.</a:t>
+              <a:t>Write, dictate or photograph what you saw. The device shows what it will share before you save.</a:t>
             </a:r>
             <a:endParaRPr lang="en-US" sz="1600" dirty="0"/>
           </a:p>
@@ -2798,7 +2798,7 @@
                 <a:ea typeface="Calibri" pitchFamily="34" charset="-122"/>
                 <a:cs typeface="Calibri" pitchFamily="34" charset="-120"/>
               </a:rPr>
-              <a:t>Search your notes and headquarters manuals in about a millisecond.</a:t>
+              <a:t>Search your notes, photos and headquarters manuals in about a millisecond.</a:t>
             </a:r>
             <a:endParaRPr lang="en-US" sz="1600" dirty="0"/>
           </a:p>
@@ -2940,7 +2940,7 @@
                 <a:ea typeface="Calibri" pitchFamily="34" charset="-122"/>
                 <a:cs typeface="Calibri" pitchFamily="34" charset="-120"/>
               </a:rPr>
-              <a:t>Get a cited answer written on the device. No cloud call.</a:t>
+              <a:t>Get a cited answer written on the device, checked against its sources. No cloud call.</a:t>
             </a:r>
             <a:endParaRPr lang="en-US" sz="1600" dirty="0"/>
           </a:p>
@@ -2978,16 +2978,55 @@
           </a:effectLst>
         </p:spPr>
       </p:sp>
+      <p:sp>
+        <p:nvSpPr>
+          <p:cNvPr id="17" name="Text 14"/>
+          <p:cNvSpPr txBox="1"/>
+          <p:nvPr/>
+        </p:nvSpPr>
+        <p:spPr>
+          <a:xfrm>
+            <a:off x="10637215" y="6309360"/>
+            <a:ext cx="914400" cy="274320"/>
+          </a:xfrm>
+          <a:prstGeom prst="rect">
+            <a:avLst/>
+          </a:prstGeom>
+          <a:noFill/>
+          <a:ln/>
+        </p:spPr>
+        <p:txBody>
+          <a:bodyPr wrap="square" lIns="0" tIns="0" rIns="0" bIns="0" rtlCol="0" anchor="t"/>
+          <a:lstStyle/>
+          <a:p>
+            <a:pPr algn="r" indent="0" marL="0">
+              <a:buNone/>
+            </a:pPr>
+            <a:r>
+              <a:rPr lang="en-US" sz="1100" dirty="0">
+                <a:solidFill>
+                  <a:srgbClr val="5F5C54"/>
+                </a:solidFill>
+                <a:latin typeface="Courier New" pitchFamily="34" charset="0"/>
+                <a:ea typeface="Courier New" pitchFamily="34" charset="-122"/>
+                <a:cs typeface="Courier New" pitchFamily="34" charset="-120"/>
+              </a:rPr>
+              <a:t>03</a:t>
+            </a:r>
+            <a:endParaRPr lang="en-US" sz="1100" dirty="0"/>
+          </a:p>
+        </p:txBody>
+      </p:sp>
       <p:pic>
         <p:nvPicPr>
-          <p:cNvPr id="16" name="Image 0" descr="C:\Users\yadav\Downloads\hcs2\docs\img\offline-work.png">    </p:cNvPr>
+          <p:cNvPr id="18" name="Picture 17" descr="offline-work.png"/>
           <p:cNvPicPr>
             <a:picLocks noChangeAspect="1"/>
           </p:cNvPicPr>
           <p:nvPr/>
         </p:nvPicPr>
         <p:blipFill>
-          <a:blip r:embed="rId1"/>
+          <a:blip r:embed="rId4"/>
           <a:stretch>
             <a:fillRect/>
           </a:stretch>
@@ -3002,45 +3041,6 @@
           </a:prstGeom>
         </p:spPr>
       </p:pic>
-      <p:sp>
-        <p:nvSpPr>
-          <p:cNvPr id="17" name="Text 14"/>
-          <p:cNvSpPr txBox="1"/>
-          <p:nvPr/>
-        </p:nvSpPr>
-        <p:spPr>
-          <a:xfrm>
-            <a:off x="10637215" y="6309360"/>
-            <a:ext cx="914400" cy="274320"/>
-          </a:xfrm>
-          <a:prstGeom prst="rect">
-            <a:avLst/>
-          </a:prstGeom>
-          <a:noFill/>
-          <a:ln/>
-        </p:spPr>
-        <p:txBody>
-          <a:bodyPr wrap="square" lIns="0" tIns="0" rIns="0" bIns="0" rtlCol="0" anchor="t"/>
-          <a:lstStyle/>
-          <a:p>
-            <a:pPr algn="r" indent="0" marL="0">
-              <a:buNone/>
-            </a:pPr>
-            <a:r>
-              <a:rPr lang="en-US" sz="1100" dirty="0">
-                <a:solidFill>
-                  <a:srgbClr val="5F5C54"/>
-                </a:solidFill>
-                <a:latin typeface="Courier New" pitchFamily="34" charset="0"/>
-                <a:ea typeface="Courier New" pitchFamily="34" charset="-122"/>
-                <a:cs typeface="Courier New" pitchFamily="34" charset="-120"/>
-              </a:rPr>
-              <a:t>03</a:t>
-            </a:r>
-            <a:endParaRPr lang="en-US" sz="1100" dirty="0"/>
-          </a:p>
-        </p:txBody>
-      </p:sp>
     </p:spTree>
   </p:cSld>
   <p:clrMapOvr>
@@ -3277,7 +3277,7 @@
                 <a:ea typeface="Calibri" pitchFamily="34" charset="-122"/>
                 <a:cs typeface="Calibri" pitchFamily="34" charset="-120"/>
               </a:rPr>
-              <a:t>Written here, private too</a:t>
+              <a:t>Written here, private too, sealed on disk</a:t>
             </a:r>
             <a:endParaRPr lang="en-US" sz="1400" dirty="0"/>
           </a:p>
@@ -3382,7 +3382,7 @@
                 <a:ea typeface="Calibri" pitchFamily="34" charset="-122"/>
                 <a:cs typeface="Calibri" pitchFamily="34" charset="-120"/>
               </a:rPr>
-              <a:t>Copy of cloud knowledge</a:t>
+              <a:t>Cloud knowledge, or from nearby devices</a:t>
             </a:r>
             <a:endParaRPr lang="en-US" sz="1400" dirty="0"/>
           </a:p>
@@ -3487,7 +3487,7 @@
                 <a:ea typeface="Calibri" pitchFamily="34" charset="-122"/>
                 <a:cs typeface="Calibri" pitchFamily="34" charset="-120"/>
               </a:rPr>
-              <a:t>Decides what may leave</a:t>
+              <a:t>Decides what may leave, learns from you</a:t>
             </a:r>
             <a:endParaRPr lang="en-US" sz="1400" dirty="0"/>
           </a:p>
@@ -3592,7 +3592,7 @@
                 <a:ea typeface="Calibri" pitchFamily="34" charset="-122"/>
                 <a:cs typeface="Calibri" pitchFamily="34" charset="-120"/>
               </a:rPr>
-              <a:t>bge-small and BM25</a:t>
+              <a:t>bge-small and BM25, MiniLM reranker, CLIP</a:t>
             </a:r>
             <a:endParaRPr lang="en-US" sz="1400" dirty="0"/>
           </a:p>
@@ -3697,7 +3697,7 @@
                 <a:ea typeface="Calibri" pitchFamily="34" charset="-122"/>
                 <a:cs typeface="Calibri" pitchFamily="34" charset="-120"/>
               </a:rPr>
-              <a:t>Outbox and conflicts</a:t>
+              <a:t>Outbox, conflicts, activity</a:t>
             </a:r>
             <a:endParaRPr lang="en-US" sz="1400" dirty="0"/>
           </a:p>
@@ -4163,42 +4163,63 @@
             </a:r>
             <a:endParaRPr lang="en-US" sz="1500" dirty="0"/>
           </a:p>
-        </p:txBody>
-      </p:sp>
-      <p:sp>
-        <p:nvSpPr>
-          <p:cNvPr id="32" name="Text 30"/>
-          <p:cNvSpPr txBox="1"/>
-          <p:nvPr/>
-        </p:nvSpPr>
-        <p:spPr>
-          <a:xfrm>
-            <a:off x="9281160" y="5166360"/>
-            <a:ext cx="1996135" cy="594360"/>
-          </a:xfrm>
-          <a:prstGeom prst="rect">
-            <a:avLst/>
-          </a:prstGeom>
-          <a:noFill/>
-          <a:ln/>
-        </p:spPr>
-        <p:txBody>
-          <a:bodyPr wrap="square" lIns="0" tIns="0" rIns="0" bIns="0" rtlCol="0" anchor="b"/>
-          <a:lstStyle/>
-          <a:p>
-            <a:pPr indent="0" marL="0">
-              <a:buNone/>
-            </a:pPr>
-            <a:r>
-              <a:rPr lang="en-US" sz="1400" dirty="0">
-                <a:solidFill>
-                  <a:srgbClr val="F29A4A"/>
+          <a:p>
+            <a:pPr marL="342900" indent="-342900">
+              <a:spcAft>
+                <a:spcPts val="800"/>
+              </a:spcAft>
+              <a:buSzPct val="100000"/>
+              <a:buChar char="•"/>
+            </a:pPr>
+            <a:r>
+              <a:rPr lang="en-US" sz="1500" dirty="0">
+                <a:solidFill>
+                  <a:srgbClr val="BDBBB0"/>
                 </a:solidFill>
                 <a:latin typeface="Calibri" pitchFamily="34" charset="0"/>
                 <a:ea typeface="Calibri" pitchFamily="34" charset="-122"/>
                 <a:cs typeface="Calibri" pitchFamily="34" charset="-120"/>
               </a:rPr>
-              <a:t>Other devices sync here too</a:t>
+              <a:t>Photo thumbnails</a:t>
+            </a:r>
+            <a:endParaRPr lang="en-US" sz="1500" dirty="0"/>
+          </a:p>
+        </p:txBody>
+      </p:sp>
+      <p:sp>
+        <p:nvSpPr>
+          <p:cNvPr id="32" name="Text 30"/>
+          <p:cNvSpPr txBox="1"/>
+          <p:nvPr/>
+        </p:nvSpPr>
+        <p:spPr>
+          <a:xfrm>
+            <a:off x="9281160" y="5166360"/>
+            <a:ext cx="1996135" cy="594360"/>
+          </a:xfrm>
+          <a:prstGeom prst="rect">
+            <a:avLst/>
+          </a:prstGeom>
+          <a:noFill/>
+          <a:ln/>
+        </p:spPr>
+        <p:txBody>
+          <a:bodyPr wrap="square" lIns="0" tIns="0" rIns="0" bIns="0" rtlCol="0" anchor="b"/>
+          <a:lstStyle/>
+          <a:p>
+            <a:pPr indent="0" marL="0">
+              <a:buNone/>
+            </a:pPr>
+            <a:r>
+              <a:rPr lang="en-US" sz="1400" dirty="0">
+                <a:solidFill>
+                  <a:srgbClr val="F29A4A"/>
+                </a:solidFill>
+                <a:latin typeface="Calibri" pitchFamily="34" charset="0"/>
+                <a:ea typeface="Calibri" pitchFamily="34" charset="-122"/>
+                <a:cs typeface="Calibri" pitchFamily="34" charset="-120"/>
+              </a:rPr>
+              <a:t>Other devices sync here, or with each other when it is gone</a:t>
             </a:r>
             <a:endParaRPr lang="en-US" sz="1400" dirty="0"/>
           </a:p>
@@ -5175,7 +5196,7 @@
                 <a:ea typeface="Calibri" pitchFamily="34" charset="-122"/>
                 <a:cs typeface="Calibri" pitchFamily="34" charset="-120"/>
               </a:rPr>
-              <a:t>Decided in about 20 ms on the device by a name recognition model, pattern detectors and a semantic classifier. Vectors for a masked note are computed from the masked text.</a:t>
+              <a:t>Decided in about 20 ms on the device by a name recognition model, pattern detectors (credentials, contacts, identity numbers, vehicles, badges, addresses) and a semantic classifier. Vectors for a masked note are computed from the masked text. Override a decision and notes like it follow your choice from then on.</a:t>
             </a:r>
             <a:endParaRPr lang="en-US" sz="1600" dirty="0"/>
           </a:p>
@@ -5427,7 +5448,7 @@
                 <a:ea typeface="Calibri" pitchFamily="34" charset="-122"/>
                 <a:cs typeface="Calibri" pitchFamily="34" charset="-120"/>
               </a:rPr>
-              <a:t>An upload only lands if the cloud is still at the version the device last saw.</a:t>
+              <a:t>An upload only lands if the cloud is still at the version the device last saw. An edit made mid-upload is rebased, not lost.</a:t>
             </a:r>
             <a:endParaRPr lang="en-US" sz="1600" dirty="0"/>
           </a:p>
@@ -5711,7 +5732,7 @@
                 <a:ea typeface="Calibri" pitchFamily="34" charset="-122"/>
                 <a:cs typeface="Calibri" pitchFamily="34" charset="-120"/>
               </a:rPr>
-              <a:t>Keep mine, accept theirs, keep both or combine. Even while offline.</a:t>
+              <a:t>Keep mine, accept theirs, keep both or combine. Even while offline. One click stages a conflict for the demo.</a:t>
             </a:r>
             <a:endParaRPr lang="en-US" sz="1600" dirty="0"/>
           </a:p>
@@ -5749,16 +5770,55 @@
           </a:effectLst>
         </p:spPr>
       </p:sp>
+      <p:sp>
+        <p:nvSpPr>
+          <p:cNvPr id="17" name="Text 14"/>
+          <p:cNvSpPr txBox="1"/>
+          <p:nvPr/>
+        </p:nvSpPr>
+        <p:spPr>
+          <a:xfrm>
+            <a:off x="10637215" y="6309360"/>
+            <a:ext cx="914400" cy="274320"/>
+          </a:xfrm>
+          <a:prstGeom prst="rect">
+            <a:avLst/>
+          </a:prstGeom>
+          <a:noFill/>
+          <a:ln/>
+        </p:spPr>
+        <p:txBody>
+          <a:bodyPr wrap="square" lIns="0" tIns="0" rIns="0" bIns="0" rtlCol="0" anchor="t"/>
+          <a:lstStyle/>
+          <a:p>
+            <a:pPr algn="r" indent="0" marL="0">
+              <a:buNone/>
+            </a:pPr>
+            <a:r>
+              <a:rPr lang="en-US" sz="1100" dirty="0">
+                <a:solidFill>
+                  <a:srgbClr val="5F5C54"/>
+                </a:solidFill>
+                <a:latin typeface="Courier New" pitchFamily="34" charset="0"/>
+                <a:ea typeface="Courier New" pitchFamily="34" charset="-122"/>
+                <a:cs typeface="Courier New" pitchFamily="34" charset="-120"/>
+              </a:rPr>
+              <a:t>06</a:t>
+            </a:r>
+            <a:endParaRPr lang="en-US" sz="1100" dirty="0"/>
+          </a:p>
+        </p:txBody>
+      </p:sp>
       <p:pic>
         <p:nvPicPr>
-          <p:cNvPr id="16" name="Image 0" descr="C:\Users\yadav\Downloads\hcs2\docs\img\conflict.png">    </p:cNvPr>
+          <p:cNvPr id="18" name="Picture 17" descr="conflict.png"/>
           <p:cNvPicPr>
             <a:picLocks noChangeAspect="1"/>
           </p:cNvPicPr>
           <p:nvPr/>
         </p:nvPicPr>
         <p:blipFill>
-          <a:blip r:embed="rId1"/>
+          <a:blip r:embed="rId4"/>
           <a:stretch>
             <a:fillRect/>
           </a:stretch>
@@ -5773,45 +5833,6 @@
           </a:prstGeom>
         </p:spPr>
       </p:pic>
-      <p:sp>
-        <p:nvSpPr>
-          <p:cNvPr id="17" name="Text 14"/>
-          <p:cNvSpPr txBox="1"/>
-          <p:nvPr/>
-        </p:nvSpPr>
-        <p:spPr>
-          <a:xfrm>
-            <a:off x="10637215" y="6309360"/>
-            <a:ext cx="914400" cy="274320"/>
-          </a:xfrm>
-          <a:prstGeom prst="rect">
-            <a:avLst/>
-          </a:prstGeom>
-          <a:noFill/>
-          <a:ln/>
-        </p:spPr>
-        <p:txBody>
-          <a:bodyPr wrap="square" lIns="0" tIns="0" rIns="0" bIns="0" rtlCol="0" anchor="t"/>
-          <a:lstStyle/>
-          <a:p>
-            <a:pPr algn="r" indent="0" marL="0">
-              <a:buNone/>
-            </a:pPr>
-            <a:r>
-              <a:rPr lang="en-US" sz="1100" dirty="0">
-                <a:solidFill>
-                  <a:srgbClr val="5F5C54"/>
-                </a:solidFill>
-                <a:latin typeface="Courier New" pitchFamily="34" charset="0"/>
-                <a:ea typeface="Courier New" pitchFamily="34" charset="-122"/>
-                <a:cs typeface="Courier New" pitchFamily="34" charset="-120"/>
-              </a:rPr>
-              <a:t>06</a:t>
-            </a:r>
-            <a:endParaRPr lang="en-US" sz="1100" dirty="0"/>
-          </a:p>
-        </p:txBody>
-      </p:sp>
     </p:spTree>
   </p:cSld>
   <p:clrMapOvr>
@@ -6130,7 +6151,7 @@
                           <a:ea typeface="Calibri" pitchFamily="34" charset="-122"/>
                           <a:cs typeface="Calibri" pitchFamily="34" charset="-120"/>
                         </a:rPr>
-                        <a:t>Two per device: local notes and a cloud replica</a:t>
+                        <a:t>Three per device: local notes, a cloud replica, and photos with a CLIP vector each</a:t>
                       </a:r>
                       <a:endParaRPr lang="en-US" sz="1600" dirty="0">
                         <a:latin typeface="Calibri" charset="0"/>
@@ -6394,7 +6415,7 @@
                           <a:ea typeface="Calibri" pitchFamily="34" charset="-122"/>
                           <a:cs typeface="Calibri" pitchFamily="34" charset="-120"/>
                         </a:rPr>
-                        <a:t>Meaning search narrowed by asset, scope and status</a:t>
+                        <a:t>Meaning search narrowed by asset, scope and status; photos found by what they show</a:t>
                       </a:r>
                       <a:endParaRPr lang="en-US" sz="1600" dirty="0">
                         <a:latin typeface="Calibri" charset="0"/>
@@ -6593,7 +6614,7 @@
                           <a:ea typeface="Calibri" pitchFamily="34" charset="-122"/>
                           <a:cs typeface="Calibri" pitchFamily="34" charset="-120"/>
                         </a:rPr>
-                        <a:t>Conditional upsert</a:t>
+                        <a:t>Conditional upsert and payload overwrite</a:t>
                       </a:r>
                       <a:endParaRPr lang="en-US" sz="1600" dirty="0">
                         <a:latin typeface="Calibri" charset="0"/>
@@ -6658,7 +6679,7 @@
                           <a:ea typeface="Calibri" pitchFamily="34" charset="-122"/>
                           <a:cs typeface="Calibri" pitchFamily="34" charset="-120"/>
                         </a:rPr>
-                        <a:t>Compare and swap, so devices never clobber each other</a:t>
+                        <a:t>Compare and swap, so devices never clobber each other; payload-only patches skip the vectors</a:t>
                       </a:r>
                       <a:endParaRPr lang="en-US" sz="1600" dirty="0">
                         <a:latin typeface="Calibri" charset="0"/>
@@ -6790,7 +6811,7 @@
                           <a:ea typeface="Calibri" pitchFamily="34" charset="-122"/>
                           <a:cs typeface="Calibri" pitchFamily="34" charset="-120"/>
                         </a:rPr>
-                        <a:t>The same dense and sparse vectors on edge and server</a:t>
+                        <a:t>The same dense and sparse vectors on edge and server, versioned payloads</a:t>
                       </a:r>
                       <a:endParaRPr lang="en-US" sz="1600" dirty="0">
                         <a:latin typeface="Calibri" charset="0"/>
@@ -6876,7 +6897,7 @@
                 <a:ea typeface="Courier New" pitchFamily="34" charset="-122"/>
                 <a:cs typeface="Courier New" pitchFamily="34" charset="-120"/>
               </a:rPr>
-              <a:t>qdrant-edge-py 0.8.0 with Qdrant Server 1.19.1</a:t>
+              <a:t>qdrant-edge-py 0.8.0 with Qdrant Server 1.19.2, pinned and tested in CI</a:t>
             </a:r>
             <a:endParaRPr lang="en-US" sz="1200" dirty="0"/>
           </a:p>
@@ -7196,7 +7217,7 @@
                 <a:ea typeface="Calibri" pitchFamily="34" charset="-122"/>
                 <a:cs typeface="Calibri" pitchFamily="34" charset="-120"/>
               </a:rPr>
-              <a:t>network calls to search or answer</a:t>
+              <a:t>network calls to search, answer or find a photo</a:t>
             </a:r>
             <a:endParaRPr lang="en-US" sz="1600" dirty="0"/>
           </a:p>
@@ -7472,7 +7493,7 @@
                 <a:ea typeface="Arial" pitchFamily="34" charset="-122"/>
                 <a:cs typeface="Arial" pitchFamily="34" charset="-120"/>
               </a:rPr>
-              <a:t>57</a:t>
+              <a:t>106</a:t>
             </a:r>
             <a:endParaRPr lang="en-US" sz="5400" dirty="0"/>
           </a:p>
@@ -7511,7 +7532,7 @@
                 <a:ea typeface="Calibri" pitchFamily="34" charset="-122"/>
                 <a:cs typeface="Calibri" pitchFamily="34" charset="-120"/>
               </a:rPr>
-              <a:t>automated tests, run on every push</a:t>
+              <a:t>tests on every push: two devices, a real Qdrant Server, a real browser</a:t>
             </a:r>
             <a:endParaRPr lang="en-US" sz="1600" dirty="0"/>
           </a:p>
@@ -7655,7 +7676,7 @@
                 <a:ea typeface="Calibri" pitchFamily="34" charset="-122"/>
                 <a:cs typeface="Calibri" pitchFamily="34" charset="-120"/>
               </a:rPr>
-              <a:t>Ryzen 7 7435HS laptop, RTX 3050 4 GB. Also verified on Linux through a real network disconnect.</a:t>
+              <a:t>Ryzen 7 7435HS laptop, RTX 3050 4 GB. Also verified on Linux through a real network disconnect, and on arm64.</a:t>
             </a:r>
             <a:endParaRPr lang="en-US" sz="1200" dirty="0"/>
           </a:p>
@@ -8280,7 +8301,7 @@
                 <a:ea typeface="Calibri" pitchFamily="34" charset="-122"/>
                 <a:cs typeface="Calibri" pitchFamily="34" charset="-120"/>
               </a:rPr>
-              <a:t>Two devices disagree, a person decides</a:t>
+              <a:t>Two devices disagree, a person decides (one click to stage)</a:t>
             </a:r>
             <a:endParaRPr lang="en-US" sz="2200" dirty="0"/>
           </a:p>
@@ -8346,7 +8367,7 @@
                 <a:ea typeface="Arial" pitchFamily="34" charset="-122"/>
                 <a:cs typeface="Arial" pitchFamily="34" charset="-120"/>
               </a:rPr>
-              <a:t>Next</a:t>
+              <a:t>Also in the box</a:t>
             </a:r>
             <a:endParaRPr lang="en-US" sz="1800" dirty="0"/>
           </a:p>
@@ -8389,7 +8410,7 @@
                 <a:ea typeface="Calibri" pitchFamily="34" charset="-122"/>
                 <a:cs typeface="Calibri" pitchFamily="34" charset="-120"/>
               </a:rPr>
-              <a:t>Encrypt notes at rest</a:t>
+              <a:t>Private text sealed on disk</a:t>
             </a:r>
             <a:endParaRPr lang="en-US" sz="1700" dirty="0"/>
           </a:p>
@@ -8410,7 +8431,7 @@
                 <a:ea typeface="Calibri" pitchFamily="34" charset="-122"/>
                 <a:cs typeface="Calibri" pitchFamily="34" charset="-120"/>
               </a:rPr>
-              <a:t>TLS for remote dashboards</a:t>
+              <a:t>Setup code claims the first PIN</a:t>
             </a:r>
             <a:endParaRPr lang="en-US" sz="1700" dirty="0"/>
           </a:p>
@@ -8431,7 +8452,70 @@
                 <a:ea typeface="Calibri" pitchFamily="34" charset="-122"/>
                 <a:cs typeface="Calibri" pitchFamily="34" charset="-120"/>
               </a:rPr>
-              <a:t>Name masking beyond English</a:t>
+              <a:t>Devices learn from each other offline</a:t>
+            </a:r>
+            <a:endParaRPr lang="en-US" sz="1700" dirty="0"/>
+          </a:p>
+          <a:p>
+            <a:pPr marL="342900" indent="-342900">
+              <a:spcAft>
+                <a:spcPts val="1200"/>
+              </a:spcAft>
+              <a:buSzPct val="100000"/>
+              <a:buChar char="•"/>
+            </a:pPr>
+            <a:r>
+              <a:rPr lang="en-US" sz="1700" dirty="0">
+                <a:solidFill>
+                  <a:srgbClr val="BDBBB0"/>
+                </a:solidFill>
+                <a:latin typeface="Calibri" pitchFamily="34" charset="0"/>
+                <a:ea typeface="Calibri" pitchFamily="34" charset="-122"/>
+                <a:cs typeface="Calibri" pitchFamily="34" charset="-120"/>
+              </a:rPr>
+              <a:t>Photos searchable by what they show</a:t>
+            </a:r>
+            <a:endParaRPr lang="en-US" sz="1700" dirty="0"/>
+          </a:p>
+          <a:p>
+            <a:pPr marL="342900" indent="-342900">
+              <a:spcAft>
+                <a:spcPts val="1200"/>
+              </a:spcAft>
+              <a:buSzPct val="100000"/>
+              <a:buChar char="•"/>
+            </a:pPr>
+            <a:r>
+              <a:rPr lang="en-US" sz="1700" dirty="0">
+                <a:solidFill>
+                  <a:srgbClr val="BDBBB0"/>
+                </a:solidFill>
+                <a:latin typeface="Calibri" pitchFamily="34" charset="0"/>
+                <a:ea typeface="Calibri" pitchFamily="34" charset="-122"/>
+                <a:cs typeface="Calibri" pitchFamily="34" charset="-120"/>
+              </a:rPr>
+              <a:t>Encrypted backup to a new device</a:t>
+            </a:r>
+            <a:endParaRPr lang="en-US" sz="1700" dirty="0"/>
+          </a:p>
+          <a:p>
+            <a:pPr marL="342900" indent="-342900">
+              <a:spcAft>
+                <a:spcPts val="1200"/>
+              </a:spcAft>
+              <a:buSzPct val="100000"/>
+              <a:buChar char="•"/>
+            </a:pPr>
+            <a:r>
+              <a:rPr lang="en-US" sz="1700" dirty="0">
+                <a:solidFill>
+                  <a:srgbClr val="BDBBB0"/>
+                </a:solidFill>
+                <a:latin typeface="Calibri" pitchFamily="34" charset="0"/>
+                <a:ea typeface="Calibri" pitchFamily="34" charset="-122"/>
+                <a:cs typeface="Calibri" pitchFamily="34" charset="-120"/>
+              </a:rPr>
+              <a:t>Shift report, phone layout, dictation</a:t>
             </a:r>
             <a:endParaRPr lang="en-US" sz="1700" dirty="0"/>
           </a:p>

</xml_diff>

<commit_message>
Deck: screenshots of the rebuilt dashboard
</commit_message>
<xml_diff>
--- a/docs/FieldMind-Compilers.pptx
+++ b/docs/FieldMind-Compilers.pptx
@@ -3026,7 +3026,7 @@
           <p:nvPr/>
         </p:nvPicPr>
         <p:blipFill>
-          <a:blip r:embed="rId4"/>
+          <a:blip r:embed="rId5"/>
           <a:stretch>
             <a:fillRect/>
           </a:stretch>
@@ -5818,7 +5818,7 @@
           <p:nvPr/>
         </p:nvPicPr>
         <p:blipFill>
-          <a:blip r:embed="rId4"/>
+          <a:blip r:embed="rId5"/>
           <a:stretch>
             <a:fillRect/>
           </a:stretch>

</xml_diff>

<commit_message>
Deck: current state, with a Try-it-live slide
On-device dictation, the hosted 24/7 setup and the new dashboard in the text;
a final slide with QR codes for the live device and the repository, and five
things to try in two minutes.
</commit_message>
<xml_diff>
--- a/docs/FieldMind-Compilers.pptx
+++ b/docs/FieldMind-Compilers.pptx
@@ -14,6 +14,7 @@
     <p:sldId id="262" r:id="rId8"/>
     <p:sldId id="263" r:id="rId9"/>
     <p:sldId id="264" r:id="rId10"/>
+    <p:sldId id="265" r:id="rId16"/>
   </p:sldIdLst>
   <p:notesMasterIdLst>
     <p:notesMasterId r:id="rId11"/>
@@ -1840,6 +1841,595 @@
 </p:sld>
 </file>
 
+<file path=ppt/slides/slide10.xml><?xml version="1.0" encoding="utf-8"?>
+<p:sld xmlns:a="http://schemas.openxmlformats.org/drawingml/2006/main" xmlns:p="http://schemas.openxmlformats.org/presentationml/2006/main" xmlns:r="http://schemas.openxmlformats.org/officeDocument/2006/relationships">
+  <p:cSld>
+    <p:bg>
+      <p:bgPr>
+        <a:solidFill>
+          <a:srgbClr val="161714"/>
+        </a:solidFill>
+        <a:effectLst/>
+      </p:bgPr>
+    </p:bg>
+    <p:spTree>
+      <p:nvGrpSpPr>
+        <p:cNvPr id="1" name=""/>
+        <p:cNvGrpSpPr/>
+        <p:nvPr/>
+      </p:nvGrpSpPr>
+      <p:grpSpPr/>
+      <p:sp>
+        <p:nvSpPr>
+          <p:cNvPr id="2" name="TextBox 1"/>
+          <p:cNvSpPr txBox="1"/>
+          <p:nvPr/>
+        </p:nvSpPr>
+        <p:spPr>
+          <a:xfrm>
+            <a:off x="640080" y="548640"/>
+            <a:ext cx="10881360" cy="822960"/>
+          </a:xfrm>
+          <a:prstGeom prst="rect">
+            <a:avLst/>
+          </a:prstGeom>
+          <a:noFill/>
+        </p:spPr>
+        <p:txBody>
+          <a:bodyPr wrap="square">
+            <a:spAutoFit/>
+          </a:bodyPr>
+          <a:lstStyle/>
+          <a:p>
+            <a:r>
+              <a:rPr sz="3600" b="1">
+                <a:solidFill>
+                  <a:srgbClr val="FFFFFF"/>
+                </a:solidFill>
+                <a:latin typeface="Arial"/>
+              </a:rPr>
+              <a:t>Try it live</a:t>
+            </a:r>
+          </a:p>
+        </p:txBody>
+      </p:sp>
+      <p:sp>
+        <p:nvSpPr>
+          <p:cNvPr id="3" name="Rounded Rectangle 2"/>
+          <p:cNvSpPr/>
+          <p:nvPr/>
+        </p:nvSpPr>
+        <p:spPr>
+          <a:xfrm>
+            <a:off x="640080" y="1737360"/>
+            <a:ext cx="5303520" cy="2743200"/>
+          </a:xfrm>
+          <a:prstGeom prst="roundRect">
+            <a:avLst>
+              <a:gd name="adj" fmla="val 8000"/>
+            </a:avLst>
+          </a:prstGeom>
+          <a:solidFill>
+            <a:srgbClr val="1E201C"/>
+          </a:solidFill>
+          <a:ln w="12700">
+            <a:solidFill>
+              <a:srgbClr val="2E302A"/>
+            </a:solidFill>
+          </a:ln>
+        </p:spPr>
+        <p:style>
+          <a:lnRef idx="1">
+            <a:schemeClr val="accent1"/>
+          </a:lnRef>
+          <a:fillRef idx="3">
+            <a:schemeClr val="accent1"/>
+          </a:fillRef>
+          <a:effectRef idx="2">
+            <a:schemeClr val="accent1"/>
+          </a:effectRef>
+          <a:fontRef idx="minor">
+            <a:schemeClr val="lt1"/>
+          </a:fontRef>
+        </p:style>
+        <p:txBody>
+          <a:bodyPr rtlCol="0" anchor="ctr"/>
+          <a:lstStyle/>
+          <a:p>
+            <a:pPr algn="ctr"/>
+          </a:p>
+        </p:txBody>
+      </p:sp>
+      <p:pic>
+        <p:nvPicPr>
+          <p:cNvPr id="4" name="Picture 3" descr="qr-edge-a.png"/>
+          <p:cNvPicPr>
+            <a:picLocks noChangeAspect="1"/>
+          </p:cNvPicPr>
+          <p:nvPr/>
+        </p:nvPicPr>
+        <p:blipFill>
+          <a:blip r:embed="rId2"/>
+          <a:stretch>
+            <a:fillRect/>
+          </a:stretch>
+        </p:blipFill>
+        <p:spPr>
+          <a:xfrm>
+            <a:off x="868680" y="1965960"/>
+            <a:ext cx="2286000" cy="2286000"/>
+          </a:xfrm>
+          <a:prstGeom prst="rect">
+            <a:avLst/>
+          </a:prstGeom>
+        </p:spPr>
+      </p:pic>
+      <p:sp>
+        <p:nvSpPr>
+          <p:cNvPr id="5" name="TextBox 4"/>
+          <p:cNvSpPr txBox="1"/>
+          <p:nvPr/>
+        </p:nvSpPr>
+        <p:spPr>
+          <a:xfrm>
+            <a:off x="3291840" y="1920240"/>
+            <a:ext cx="2560320" cy="365760"/>
+          </a:xfrm>
+          <a:prstGeom prst="rect">
+            <a:avLst/>
+          </a:prstGeom>
+          <a:noFill/>
+        </p:spPr>
+        <p:txBody>
+          <a:bodyPr wrap="square">
+            <a:spAutoFit/>
+          </a:bodyPr>
+          <a:lstStyle/>
+          <a:p>
+            <a:r>
+              <a:rPr sz="1200" b="1">
+                <a:solidFill>
+                  <a:srgbClr val="F29A4A"/>
+                </a:solidFill>
+                <a:latin typeface="Courier New"/>
+              </a:rPr>
+              <a:t>LIVE DEVICE</a:t>
+            </a:r>
+          </a:p>
+        </p:txBody>
+      </p:sp>
+      <p:sp>
+        <p:nvSpPr>
+          <p:cNvPr id="6" name="TextBox 5"/>
+          <p:cNvSpPr txBox="1"/>
+          <p:nvPr/>
+        </p:nvSpPr>
+        <p:spPr>
+          <a:xfrm>
+            <a:off x="3291840" y="2286000"/>
+            <a:ext cx="2560320" cy="731520"/>
+          </a:xfrm>
+          <a:prstGeom prst="rect">
+            <a:avLst/>
+          </a:prstGeom>
+          <a:noFill/>
+        </p:spPr>
+        <p:txBody>
+          <a:bodyPr wrap="square">
+            <a:spAutoFit/>
+          </a:bodyPr>
+          <a:lstStyle/>
+          <a:p>
+            <a:r>
+              <a:rPr sz="1600" b="1">
+                <a:solidFill>
+                  <a:srgbClr val="FFFFFF"/>
+                </a:solidFill>
+                <a:latin typeface="Arial"/>
+              </a:rPr>
+              <a:t>fieldmindedgea.hidenplay.net</a:t>
+            </a:r>
+          </a:p>
+        </p:txBody>
+      </p:sp>
+      <p:sp>
+        <p:nvSpPr>
+          <p:cNvPr id="7" name="TextBox 6"/>
+          <p:cNvSpPr txBox="1"/>
+          <p:nvPr/>
+        </p:nvSpPr>
+        <p:spPr>
+          <a:xfrm>
+            <a:off x="3291840" y="2926080"/>
+            <a:ext cx="2560320" cy="1463040"/>
+          </a:xfrm>
+          <a:prstGeom prst="rect">
+            <a:avLst/>
+          </a:prstGeom>
+          <a:noFill/>
+        </p:spPr>
+        <p:txBody>
+          <a:bodyPr wrap="square">
+            <a:spAutoFit/>
+          </a:bodyPr>
+          <a:lstStyle/>
+          <a:p>
+            <a:r>
+              <a:rPr sz="1300" b="0">
+                <a:solidFill>
+                  <a:srgbClr val="BDBBB0"/>
+                </a:solidFill>
+                <a:latin typeface="Calibri"/>
+              </a:rPr>
+              <a:t>edge-a, running 24/7 on an arm64 server with Qdrant Cloud. Ask us for the PIN, then click Demo guide. A second device, edge-b, syncs with it.</a:t>
+            </a:r>
+          </a:p>
+        </p:txBody>
+      </p:sp>
+      <p:sp>
+        <p:nvSpPr>
+          <p:cNvPr id="8" name="Rounded Rectangle 7"/>
+          <p:cNvSpPr/>
+          <p:nvPr/>
+        </p:nvSpPr>
+        <p:spPr>
+          <a:xfrm>
+            <a:off x="6217920" y="1737360"/>
+            <a:ext cx="5303520" cy="2743200"/>
+          </a:xfrm>
+          <a:prstGeom prst="roundRect">
+            <a:avLst>
+              <a:gd name="adj" fmla="val 8000"/>
+            </a:avLst>
+          </a:prstGeom>
+          <a:solidFill>
+            <a:srgbClr val="1E201C"/>
+          </a:solidFill>
+          <a:ln w="12700">
+            <a:solidFill>
+              <a:srgbClr val="2E302A"/>
+            </a:solidFill>
+          </a:ln>
+        </p:spPr>
+        <p:style>
+          <a:lnRef idx="1">
+            <a:schemeClr val="accent1"/>
+          </a:lnRef>
+          <a:fillRef idx="3">
+            <a:schemeClr val="accent1"/>
+          </a:fillRef>
+          <a:effectRef idx="2">
+            <a:schemeClr val="accent1"/>
+          </a:effectRef>
+          <a:fontRef idx="minor">
+            <a:schemeClr val="lt1"/>
+          </a:fontRef>
+        </p:style>
+        <p:txBody>
+          <a:bodyPr rtlCol="0" anchor="ctr"/>
+          <a:lstStyle/>
+          <a:p>
+            <a:pPr algn="ctr"/>
+          </a:p>
+        </p:txBody>
+      </p:sp>
+      <p:pic>
+        <p:nvPicPr>
+          <p:cNvPr id="9" name="Picture 8" descr="qr-repo.png"/>
+          <p:cNvPicPr>
+            <a:picLocks noChangeAspect="1"/>
+          </p:cNvPicPr>
+          <p:nvPr/>
+        </p:nvPicPr>
+        <p:blipFill>
+          <a:blip r:embed="rId3"/>
+          <a:stretch>
+            <a:fillRect/>
+          </a:stretch>
+        </p:blipFill>
+        <p:spPr>
+          <a:xfrm>
+            <a:off x="6446520" y="1965960"/>
+            <a:ext cx="2286000" cy="2286000"/>
+          </a:xfrm>
+          <a:prstGeom prst="rect">
+            <a:avLst/>
+          </a:prstGeom>
+        </p:spPr>
+      </p:pic>
+      <p:sp>
+        <p:nvSpPr>
+          <p:cNvPr id="10" name="TextBox 9"/>
+          <p:cNvSpPr txBox="1"/>
+          <p:nvPr/>
+        </p:nvSpPr>
+        <p:spPr>
+          <a:xfrm>
+            <a:off x="8869680" y="1920240"/>
+            <a:ext cx="2560320" cy="365760"/>
+          </a:xfrm>
+          <a:prstGeom prst="rect">
+            <a:avLst/>
+          </a:prstGeom>
+          <a:noFill/>
+        </p:spPr>
+        <p:txBody>
+          <a:bodyPr wrap="square">
+            <a:spAutoFit/>
+          </a:bodyPr>
+          <a:lstStyle/>
+          <a:p>
+            <a:r>
+              <a:rPr sz="1200" b="1">
+                <a:solidFill>
+                  <a:srgbClr val="F29A4A"/>
+                </a:solidFill>
+                <a:latin typeface="Courier New"/>
+              </a:rPr>
+              <a:t>CODE AND TESTS</a:t>
+            </a:r>
+          </a:p>
+        </p:txBody>
+      </p:sp>
+      <p:sp>
+        <p:nvSpPr>
+          <p:cNvPr id="11" name="TextBox 10"/>
+          <p:cNvSpPr txBox="1"/>
+          <p:nvPr/>
+        </p:nvSpPr>
+        <p:spPr>
+          <a:xfrm>
+            <a:off x="8869680" y="2286000"/>
+            <a:ext cx="2560320" cy="731520"/>
+          </a:xfrm>
+          <a:prstGeom prst="rect">
+            <a:avLst/>
+          </a:prstGeom>
+          <a:noFill/>
+        </p:spPr>
+        <p:txBody>
+          <a:bodyPr wrap="square">
+            <a:spAutoFit/>
+          </a:bodyPr>
+          <a:lstStyle/>
+          <a:p>
+            <a:r>
+              <a:rPr sz="1600" b="1">
+                <a:solidFill>
+                  <a:srgbClr val="FFFFFF"/>
+                </a:solidFill>
+                <a:latin typeface="Arial"/>
+              </a:rPr>
+              <a:t>github.com/yabhinav1/fieldmind</a:t>
+            </a:r>
+          </a:p>
+        </p:txBody>
+      </p:sp>
+      <p:sp>
+        <p:nvSpPr>
+          <p:cNvPr id="12" name="TextBox 11"/>
+          <p:cNvSpPr txBox="1"/>
+          <p:nvPr/>
+        </p:nvSpPr>
+        <p:spPr>
+          <a:xfrm>
+            <a:off x="8869680" y="2926080"/>
+            <a:ext cx="2560320" cy="1463040"/>
+          </a:xfrm>
+          <a:prstGeom prst="rect">
+            <a:avLst/>
+          </a:prstGeom>
+          <a:noFill/>
+        </p:spPr>
+        <p:txBody>
+          <a:bodyPr wrap="square">
+            <a:spAutoFit/>
+          </a:bodyPr>
+          <a:lstStyle/>
+          <a:p>
+            <a:r>
+              <a:rPr sz="1300" b="0">
+                <a:solidFill>
+                  <a:srgbClr val="BDBBB0"/>
+                </a:solidFill>
+                <a:latin typeface="Calibri"/>
+              </a:rPr>
+              <a:t>MIT. 106 tests on every push against a real Qdrant Server and a real browser. docker compose --profile demo up runs it on any laptop.</a:t>
+            </a:r>
+          </a:p>
+        </p:txBody>
+      </p:sp>
+      <p:sp>
+        <p:nvSpPr>
+          <p:cNvPr id="13" name="Rounded Rectangle 12"/>
+          <p:cNvSpPr/>
+          <p:nvPr/>
+        </p:nvSpPr>
+        <p:spPr>
+          <a:xfrm>
+            <a:off x="640080" y="4754880"/>
+            <a:ext cx="10881360" cy="1188720"/>
+          </a:xfrm>
+          <a:prstGeom prst="roundRect">
+            <a:avLst>
+              <a:gd name="adj" fmla="val 8000"/>
+            </a:avLst>
+          </a:prstGeom>
+          <a:solidFill>
+            <a:srgbClr val="1E201C"/>
+          </a:solidFill>
+          <a:ln w="12700">
+            <a:solidFill>
+              <a:srgbClr val="2E302A"/>
+            </a:solidFill>
+          </a:ln>
+        </p:spPr>
+        <p:style>
+          <a:lnRef idx="1">
+            <a:schemeClr val="accent1"/>
+          </a:lnRef>
+          <a:fillRef idx="3">
+            <a:schemeClr val="accent1"/>
+          </a:fillRef>
+          <a:effectRef idx="2">
+            <a:schemeClr val="accent1"/>
+          </a:effectRef>
+          <a:fontRef idx="minor">
+            <a:schemeClr val="lt1"/>
+          </a:fontRef>
+        </p:style>
+        <p:txBody>
+          <a:bodyPr rtlCol="0" anchor="ctr"/>
+          <a:lstStyle/>
+          <a:p>
+            <a:pPr algn="ctr"/>
+          </a:p>
+        </p:txBody>
+      </p:sp>
+      <p:sp>
+        <p:nvSpPr>
+          <p:cNvPr id="14" name="TextBox 13"/>
+          <p:cNvSpPr txBox="1"/>
+          <p:nvPr/>
+        </p:nvSpPr>
+        <p:spPr>
+          <a:xfrm>
+            <a:off x="914400" y="4846320"/>
+            <a:ext cx="10332720" cy="365760"/>
+          </a:xfrm>
+          <a:prstGeom prst="rect">
+            <a:avLst/>
+          </a:prstGeom>
+          <a:noFill/>
+        </p:spPr>
+        <p:txBody>
+          <a:bodyPr wrap="square">
+            <a:spAutoFit/>
+          </a:bodyPr>
+          <a:lstStyle/>
+          <a:p>
+            <a:r>
+              <a:rPr sz="1200" b="1">
+                <a:solidFill>
+                  <a:srgbClr val="F29A4A"/>
+                </a:solidFill>
+                <a:latin typeface="Courier New"/>
+              </a:rPr>
+              <a:t>FIVE THINGS TO TRY IN TWO MINUTES</a:t>
+            </a:r>
+          </a:p>
+        </p:txBody>
+      </p:sp>
+      <p:sp>
+        <p:nvSpPr>
+          <p:cNvPr id="15" name="TextBox 14"/>
+          <p:cNvSpPr txBox="1"/>
+          <p:nvPr/>
+        </p:nvSpPr>
+        <p:spPr>
+          <a:xfrm>
+            <a:off x="914400" y="5212080"/>
+            <a:ext cx="10332720" cy="731520"/>
+          </a:xfrm>
+          <a:prstGeom prst="rect">
+            <a:avLst/>
+          </a:prstGeom>
+          <a:noFill/>
+        </p:spPr>
+        <p:txBody>
+          <a:bodyPr wrap="square">
+            <a:spAutoFit/>
+          </a:bodyPr>
+          <a:lstStyle/>
+          <a:p>
+            <a:r>
+              <a:rPr sz="1400" b="0">
+                <a:solidFill>
+                  <a:srgbClr val="ECEBE4"/>
+                </a:solidFill>
+                <a:latin typeface="Calibri"/>
+              </a:rPr>
+              <a:t>Network switch off, keep working  ·  Dictate a note  ·  Ask “is a vibration of 7.2 mm/s acceptable”  ·  Type a note with a name and a phone number, watch the preview mask them  ·  Demo guide → Stage a conflict, then decide</a:t>
+            </a:r>
+          </a:p>
+        </p:txBody>
+      </p:sp>
+      <p:sp>
+        <p:nvSpPr>
+          <p:cNvPr id="16" name="TextBox 15"/>
+          <p:cNvSpPr txBox="1"/>
+          <p:nvPr/>
+        </p:nvSpPr>
+        <p:spPr>
+          <a:xfrm>
+            <a:off x="640080" y="6217920"/>
+            <a:ext cx="8229600" cy="274320"/>
+          </a:xfrm>
+          <a:prstGeom prst="rect">
+            <a:avLst/>
+          </a:prstGeom>
+          <a:noFill/>
+        </p:spPr>
+        <p:txBody>
+          <a:bodyPr wrap="square">
+            <a:spAutoFit/>
+          </a:bodyPr>
+          <a:lstStyle/>
+          <a:p>
+            <a:r>
+              <a:rPr sz="1200" b="0">
+                <a:solidFill>
+                  <a:srgbClr val="9C998D"/>
+                </a:solidFill>
+                <a:latin typeface="Courier New"/>
+              </a:rPr>
+              <a:t>Team Compilers  ·  Problem statement 03  ·  Qdrant Edge</a:t>
+            </a:r>
+          </a:p>
+        </p:txBody>
+      </p:sp>
+      <p:sp>
+        <p:nvSpPr>
+          <p:cNvPr id="17" name="TextBox 16"/>
+          <p:cNvSpPr txBox="1"/>
+          <p:nvPr/>
+        </p:nvSpPr>
+        <p:spPr>
+          <a:xfrm>
+            <a:off x="10607040" y="6309360"/>
+            <a:ext cx="914400" cy="274320"/>
+          </a:xfrm>
+          <a:prstGeom prst="rect">
+            <a:avLst/>
+          </a:prstGeom>
+          <a:noFill/>
+        </p:spPr>
+        <p:txBody>
+          <a:bodyPr wrap="square">
+            <a:spAutoFit/>
+          </a:bodyPr>
+          <a:lstStyle/>
+          <a:p>
+            <a:r>
+              <a:rPr sz="1100" b="0">
+                <a:solidFill>
+                  <a:srgbClr val="9C998D"/>
+                </a:solidFill>
+                <a:latin typeface="Courier New"/>
+              </a:rPr>
+              <a:t>10</a:t>
+            </a:r>
+          </a:p>
+        </p:txBody>
+      </p:sp>
+    </p:spTree>
+  </p:cSld>
+  <p:clrMapOvr>
+    <a:masterClrMapping/>
+  </p:clrMapOvr>
+</p:sld>
+</file>
+
 <file path=ppt/slides/slide2.xml><?xml version="1.0" encoding="utf-8"?>
 <p:sld xmlns:a="http://schemas.openxmlformats.org/drawingml/2006/main" xmlns:r="http://schemas.openxmlformats.org/officeDocument/2006/relationships" xmlns:p="http://schemas.openxmlformats.org/presentationml/2006/main">
   <p:cSld name="Slide 2">
@@ -2656,7 +3246,7 @@
                 <a:ea typeface="Calibri" pitchFamily="34" charset="-122"/>
                 <a:cs typeface="Calibri" pitchFamily="34" charset="-120"/>
               </a:rPr>
-              <a:t>Write, dictate or photograph what you saw. The device shows what it will share before you save.</a:t>
+              <a:t>Write, dictate or photograph what you saw. Speech is transcribed on the device. The preview shows what will be shared before you save.</a:t>
             </a:r>
             <a:endParaRPr lang="en-US" sz="1600" dirty="0"/>
           </a:p>
@@ -7676,7 +8266,7 @@
                 <a:ea typeface="Calibri" pitchFamily="34" charset="-122"/>
                 <a:cs typeface="Calibri" pitchFamily="34" charset="-120"/>
               </a:rPr>
-              <a:t>Ryzen 7 7435HS laptop, RTX 3050 4 GB. Also verified on Linux through a real network disconnect, and on arm64.</a:t>
+              <a:t>Ryzen 7 7435HS laptop, RTX 3050 4 GB. Also verified on Linux, and in production on two arm64 servers with Qdrant Cloud.</a:t>
             </a:r>
             <a:endParaRPr lang="en-US" sz="1200" dirty="0"/>
           </a:p>
@@ -8410,7 +9000,7 @@
                 <a:ea typeface="Calibri" pitchFamily="34" charset="-122"/>
                 <a:cs typeface="Calibri" pitchFamily="34" charset="-120"/>
               </a:rPr>
-              <a:t>Private text sealed on disk</a:t>
+              <a:t>Dictation transcribed on the device (Whisper)</a:t>
             </a:r>
             <a:endParaRPr lang="en-US" sz="1700" dirty="0"/>
           </a:p>
@@ -8431,7 +9021,7 @@
                 <a:ea typeface="Calibri" pitchFamily="34" charset="-122"/>
                 <a:cs typeface="Calibri" pitchFamily="34" charset="-120"/>
               </a:rPr>
-              <a:t>Setup code claims the first PIN</a:t>
+              <a:t>Private text sealed on disk</a:t>
             </a:r>
             <a:endParaRPr lang="en-US" sz="1700" dirty="0"/>
           </a:p>
@@ -8452,7 +9042,7 @@
                 <a:ea typeface="Calibri" pitchFamily="34" charset="-122"/>
                 <a:cs typeface="Calibri" pitchFamily="34" charset="-120"/>
               </a:rPr>
-              <a:t>Devices learn from each other offline</a:t>
+              <a:t>Devices learn from each other when the cloud is gone</a:t>
             </a:r>
             <a:endParaRPr lang="en-US" sz="1700" dirty="0"/>
           </a:p>
@@ -8494,7 +9084,7 @@
                 <a:ea typeface="Calibri" pitchFamily="34" charset="-122"/>
                 <a:cs typeface="Calibri" pitchFamily="34" charset="-120"/>
               </a:rPr>
-              <a:t>Encrypted backup to a new device</a:t>
+              <a:t>Encrypted backup, shift report, one-click conflict</a:t>
             </a:r>
             <a:endParaRPr lang="en-US" sz="1700" dirty="0"/>
           </a:p>
@@ -8515,7 +9105,7 @@
                 <a:ea typeface="Calibri" pitchFamily="34" charset="-122"/>
                 <a:cs typeface="Calibri" pitchFamily="34" charset="-120"/>
               </a:rPr>
-              <a:t>Shift report, phone layout, dictation</a:t>
+              <a:t>Installable on a phone; Hindi optional</a:t>
             </a:r>
             <a:endParaRPr lang="en-US" sz="1700" dirty="0"/>
           </a:p>

</xml_diff>

<commit_message>
Docs: hands-free dictation in any language, 111 tests, model sizes, page wording
</commit_message>
<xml_diff>
--- a/docs/FieldMind-Compilers.pptx
+++ b/docs/FieldMind-Compilers.pptx
@@ -1612,6 +1612,10 @@
             <a:prstDash val="solid"/>
           </a:ln>
         </p:spPr>
+        <p:txBody>
+          <a:bodyPr/>
+          <a:p/>
+        </p:txBody>
       </p:sp>
       <p:sp>
         <p:nvSpPr>
@@ -1637,6 +1641,10 @@
             <a:prstDash val="solid"/>
           </a:ln>
         </p:spPr>
+        <p:txBody>
+          <a:bodyPr/>
+          <a:p/>
+        </p:txBody>
       </p:sp>
       <p:sp>
         <p:nvSpPr>
@@ -2234,7 +2242,7 @@
                 </a:solidFill>
                 <a:latin typeface="Calibri"/>
               </a:rPr>
-              <a:t>MIT. 106 tests on every push against a real Qdrant Server and a real browser. docker compose --profile demo up runs it on any laptop.</a:t>
+              <a:t>MIT. 111 tests on every push against a real Qdrant Server and a real browser. docker compose --profile demo up runs it on any laptop.</a:t>
             </a:r>
           </a:p>
         </p:txBody>
@@ -2349,7 +2357,7 @@
                 </a:solidFill>
                 <a:latin typeface="Calibri"/>
               </a:rPr>
-              <a:t>Network switch off, keep working  ·  Dictate a note  ·  Ask “is a vibration of 7.2 mm/s acceptable”  ·  Type a note with a name and a phone number, watch the preview mask them  ·  Demo guide → Stage a conflict, then decide</a:t>
+              <a:t>Network switch off, keep working  ·  Dictate: just talk, in any language  ·  Ask “is a vibration of 7.2 mm/s acceptable”  ·  Type a note with a name and a phone number, watch the preview mask them  ·  Demo guide → Stage a conflict, then decide</a:t>
             </a:r>
           </a:p>
         </p:txBody>
@@ -2519,6 +2527,10 @@
             <a:prstDash val="solid"/>
           </a:ln>
         </p:spPr>
+        <p:txBody>
+          <a:bodyPr/>
+          <a:p/>
+        </p:txBody>
       </p:sp>
       <p:sp>
         <p:nvSpPr>
@@ -2544,6 +2556,10 @@
             <a:prstDash val="solid"/>
           </a:ln>
         </p:spPr>
+        <p:txBody>
+          <a:bodyPr/>
+          <a:p/>
+        </p:txBody>
       </p:sp>
       <p:sp>
         <p:nvSpPr>
@@ -2688,6 +2704,10 @@
             <a:prstDash val="solid"/>
           </a:ln>
         </p:spPr>
+        <p:txBody>
+          <a:bodyPr/>
+          <a:p/>
+        </p:txBody>
       </p:sp>
       <p:sp>
         <p:nvSpPr>
@@ -2713,6 +2733,10 @@
             <a:prstDash val="solid"/>
           </a:ln>
         </p:spPr>
+        <p:txBody>
+          <a:bodyPr/>
+          <a:p/>
+        </p:txBody>
       </p:sp>
       <p:sp>
         <p:nvSpPr>
@@ -2857,6 +2881,10 @@
             <a:prstDash val="solid"/>
           </a:ln>
         </p:spPr>
+        <p:txBody>
+          <a:bodyPr/>
+          <a:p/>
+        </p:txBody>
       </p:sp>
       <p:sp>
         <p:nvSpPr>
@@ -2882,6 +2910,10 @@
             <a:prstDash val="solid"/>
           </a:ln>
         </p:spPr>
+        <p:txBody>
+          <a:bodyPr/>
+          <a:p/>
+        </p:txBody>
       </p:sp>
       <p:sp>
         <p:nvSpPr>
@@ -3134,6 +3166,10 @@
             <a:prstDash val="solid"/>
           </a:ln>
         </p:spPr>
+        <p:txBody>
+          <a:bodyPr/>
+          <a:p/>
+        </p:txBody>
       </p:sp>
       <p:sp>
         <p:nvSpPr>
@@ -3246,7 +3282,7 @@
                 <a:ea typeface="Calibri" pitchFamily="34" charset="-122"/>
                 <a:cs typeface="Calibri" pitchFamily="34" charset="-120"/>
               </a:rPr>
-              <a:t>Write, dictate or photograph what you saw. Speech is transcribed on the device. The preview shows what will be shared before you save.</a:t>
+              <a:t>Write, dictate or photograph what you saw. Hands-free dictation in any language, transcribed on the device. The preview shows what will be shared before you save.</a:t>
             </a:r>
             <a:endParaRPr lang="en-US" sz="1600" dirty="0"/>
           </a:p>
@@ -3276,6 +3312,10 @@
             <a:prstDash val="solid"/>
           </a:ln>
         </p:spPr>
+        <p:txBody>
+          <a:bodyPr/>
+          <a:p/>
+        </p:txBody>
       </p:sp>
       <p:sp>
         <p:nvSpPr>
@@ -3418,6 +3458,10 @@
             <a:prstDash val="solid"/>
           </a:ln>
         </p:spPr>
+        <p:txBody>
+          <a:bodyPr/>
+          <a:p/>
+        </p:txBody>
       </p:sp>
       <p:sp>
         <p:nvSpPr>
@@ -3567,6 +3611,10 @@
             </a:outerShdw>
           </a:effectLst>
         </p:spPr>
+        <p:txBody>
+          <a:bodyPr/>
+          <a:p/>
+        </p:txBody>
       </p:sp>
       <p:sp>
         <p:nvSpPr>
@@ -3728,6 +3776,10 @@
             <a:prstDash val="solid"/>
           </a:ln>
         </p:spPr>
+        <p:txBody>
+          <a:bodyPr/>
+          <a:p/>
+        </p:txBody>
       </p:sp>
       <p:sp>
         <p:nvSpPr>
@@ -3794,6 +3846,10 @@
             <a:prstDash val="solid"/>
           </a:ln>
         </p:spPr>
+        <p:txBody>
+          <a:bodyPr/>
+          <a:p/>
+        </p:txBody>
       </p:sp>
       <p:sp>
         <p:nvSpPr>
@@ -3899,6 +3955,10 @@
             <a:prstDash val="solid"/>
           </a:ln>
         </p:spPr>
+        <p:txBody>
+          <a:bodyPr/>
+          <a:p/>
+        </p:txBody>
       </p:sp>
       <p:sp>
         <p:nvSpPr>
@@ -4004,6 +4064,10 @@
             <a:prstDash val="solid"/>
           </a:ln>
         </p:spPr>
+        <p:txBody>
+          <a:bodyPr/>
+          <a:p/>
+        </p:txBody>
       </p:sp>
       <p:sp>
         <p:nvSpPr>
@@ -4109,6 +4173,10 @@
             <a:prstDash val="solid"/>
           </a:ln>
         </p:spPr>
+        <p:txBody>
+          <a:bodyPr/>
+          <a:p/>
+        </p:txBody>
       </p:sp>
       <p:sp>
         <p:nvSpPr>
@@ -4214,6 +4282,10 @@
             <a:prstDash val="solid"/>
           </a:ln>
         </p:spPr>
+        <p:txBody>
+          <a:bodyPr/>
+          <a:p/>
+        </p:txBody>
       </p:sp>
       <p:sp>
         <p:nvSpPr>
@@ -4319,6 +4391,10 @@
             <a:prstDash val="solid"/>
           </a:ln>
         </p:spPr>
+        <p:txBody>
+          <a:bodyPr/>
+          <a:p/>
+        </p:txBody>
       </p:sp>
       <p:sp>
         <p:nvSpPr>
@@ -4461,6 +4537,10 @@
             <a:prstDash val="solid"/>
           </a:ln>
         </p:spPr>
+        <p:txBody>
+          <a:bodyPr/>
+          <a:p/>
+        </p:txBody>
       </p:sp>
       <p:sp>
         <p:nvSpPr>
@@ -4564,6 +4644,10 @@
             <a:prstDash val="solid"/>
           </a:ln>
         </p:spPr>
+        <p:txBody>
+          <a:bodyPr/>
+          <a:p/>
+        </p:txBody>
       </p:sp>
       <p:sp>
         <p:nvSpPr>
@@ -4630,6 +4714,10 @@
             <a:prstDash val="solid"/>
           </a:ln>
         </p:spPr>
+        <p:txBody>
+          <a:bodyPr/>
+          <a:p/>
+        </p:txBody>
       </p:sp>
       <p:sp>
         <p:nvSpPr>
@@ -5926,6 +6014,10 @@
             <a:prstDash val="solid"/>
           </a:ln>
         </p:spPr>
+        <p:txBody>
+          <a:bodyPr/>
+          <a:p/>
+        </p:txBody>
       </p:sp>
       <p:sp>
         <p:nvSpPr>
@@ -6068,6 +6160,10 @@
             <a:prstDash val="solid"/>
           </a:ln>
         </p:spPr>
+        <p:txBody>
+          <a:bodyPr/>
+          <a:p/>
+        </p:txBody>
       </p:sp>
       <p:sp>
         <p:nvSpPr>
@@ -6210,6 +6306,10 @@
             <a:prstDash val="solid"/>
           </a:ln>
         </p:spPr>
+        <p:txBody>
+          <a:bodyPr/>
+          <a:p/>
+        </p:txBody>
       </p:sp>
       <p:sp>
         <p:nvSpPr>
@@ -6359,6 +6459,10 @@
             </a:outerShdw>
           </a:effectLst>
         </p:spPr>
+        <p:txBody>
+          <a:bodyPr/>
+          <a:p/>
+        </p:txBody>
       </p:sp>
       <p:sp>
         <p:nvSpPr>
@@ -7629,6 +7733,10 @@
             <a:prstDash val="solid"/>
           </a:ln>
         </p:spPr>
+        <p:txBody>
+          <a:bodyPr/>
+          <a:p/>
+        </p:txBody>
       </p:sp>
       <p:sp>
         <p:nvSpPr>
@@ -7734,6 +7842,10 @@
             <a:prstDash val="solid"/>
           </a:ln>
         </p:spPr>
+        <p:txBody>
+          <a:bodyPr/>
+          <a:p/>
+        </p:txBody>
       </p:sp>
       <p:sp>
         <p:nvSpPr>
@@ -7839,6 +7951,10 @@
             <a:prstDash val="solid"/>
           </a:ln>
         </p:spPr>
+        <p:txBody>
+          <a:bodyPr/>
+          <a:p/>
+        </p:txBody>
       </p:sp>
       <p:sp>
         <p:nvSpPr>
@@ -7944,6 +8060,10 @@
             <a:prstDash val="solid"/>
           </a:ln>
         </p:spPr>
+        <p:txBody>
+          <a:bodyPr/>
+          <a:p/>
+        </p:txBody>
       </p:sp>
       <p:sp>
         <p:nvSpPr>
@@ -8049,6 +8169,10 @@
             <a:prstDash val="solid"/>
           </a:ln>
         </p:spPr>
+        <p:txBody>
+          <a:bodyPr/>
+          <a:p/>
+        </p:txBody>
       </p:sp>
       <p:sp>
         <p:nvSpPr>
@@ -8083,7 +8207,7 @@
                 <a:ea typeface="Arial" pitchFamily="34" charset="-122"/>
                 <a:cs typeface="Arial" pitchFamily="34" charset="-120"/>
               </a:rPr>
-              <a:t>106</a:t>
+              <a:t>111</a:t>
             </a:r>
             <a:endParaRPr lang="en-US" sz="5400" dirty="0"/>
           </a:p>
@@ -8154,6 +8278,10 @@
             <a:prstDash val="solid"/>
           </a:ln>
         </p:spPr>
+        <p:txBody>
+          <a:bodyPr/>
+          <a:p/>
+        </p:txBody>
       </p:sp>
       <p:sp>
         <p:nvSpPr>
@@ -8406,6 +8534,10 @@
             <a:prstDash val="solid"/>
           </a:ln>
         </p:spPr>
+        <p:txBody>
+          <a:bodyPr/>
+          <a:p/>
+        </p:txBody>
       </p:sp>
       <p:sp>
         <p:nvSpPr>
@@ -8509,6 +8641,10 @@
             <a:prstDash val="solid"/>
           </a:ln>
         </p:spPr>
+        <p:txBody>
+          <a:bodyPr/>
+          <a:p/>
+        </p:txBody>
       </p:sp>
       <p:sp>
         <p:nvSpPr>
@@ -8612,6 +8748,10 @@
             <a:prstDash val="solid"/>
           </a:ln>
         </p:spPr>
+        <p:txBody>
+          <a:bodyPr/>
+          <a:p/>
+        </p:txBody>
       </p:sp>
       <p:sp>
         <p:nvSpPr>
@@ -8715,6 +8855,10 @@
             <a:prstDash val="solid"/>
           </a:ln>
         </p:spPr>
+        <p:txBody>
+          <a:bodyPr/>
+          <a:p/>
+        </p:txBody>
       </p:sp>
       <p:sp>
         <p:nvSpPr>
@@ -8818,6 +8962,10 @@
             <a:prstDash val="solid"/>
           </a:ln>
         </p:spPr>
+        <p:txBody>
+          <a:bodyPr/>
+          <a:p/>
+        </p:txBody>
       </p:sp>
       <p:sp>
         <p:nvSpPr>
@@ -8923,6 +9071,10 @@
             <a:prstDash val="solid"/>
           </a:ln>
         </p:spPr>
+        <p:txBody>
+          <a:bodyPr/>
+          <a:p/>
+        </p:txBody>
       </p:sp>
       <p:sp>
         <p:nvSpPr>
@@ -9000,112 +9152,7 @@
                 <a:ea typeface="Calibri" pitchFamily="34" charset="-122"/>
                 <a:cs typeface="Calibri" pitchFamily="34" charset="-120"/>
               </a:rPr>
-              <a:t>Dictation transcribed on the device (Whisper)</a:t>
-            </a:r>
-            <a:endParaRPr lang="en-US" sz="1700" dirty="0"/>
-          </a:p>
-          <a:p>
-            <a:pPr marL="342900" indent="-342900">
-              <a:spcAft>
-                <a:spcPts val="1200"/>
-              </a:spcAft>
-              <a:buSzPct val="100000"/>
-              <a:buChar char="•"/>
-            </a:pPr>
-            <a:r>
-              <a:rPr lang="en-US" sz="1700" dirty="0">
-                <a:solidFill>
-                  <a:srgbClr val="BDBBB0"/>
-                </a:solidFill>
-                <a:latin typeface="Calibri" pitchFamily="34" charset="0"/>
-                <a:ea typeface="Calibri" pitchFamily="34" charset="-122"/>
-                <a:cs typeface="Calibri" pitchFamily="34" charset="-120"/>
-              </a:rPr>
-              <a:t>Private text sealed on disk</a:t>
-            </a:r>
-            <a:endParaRPr lang="en-US" sz="1700" dirty="0"/>
-          </a:p>
-          <a:p>
-            <a:pPr marL="342900" indent="-342900">
-              <a:spcAft>
-                <a:spcPts val="1200"/>
-              </a:spcAft>
-              <a:buSzPct val="100000"/>
-              <a:buChar char="•"/>
-            </a:pPr>
-            <a:r>
-              <a:rPr lang="en-US" sz="1700" dirty="0">
-                <a:solidFill>
-                  <a:srgbClr val="BDBBB0"/>
-                </a:solidFill>
-                <a:latin typeface="Calibri" pitchFamily="34" charset="0"/>
-                <a:ea typeface="Calibri" pitchFamily="34" charset="-122"/>
-                <a:cs typeface="Calibri" pitchFamily="34" charset="-120"/>
-              </a:rPr>
-              <a:t>Devices learn from each other when the cloud is gone</a:t>
-            </a:r>
-            <a:endParaRPr lang="en-US" sz="1700" dirty="0"/>
-          </a:p>
-          <a:p>
-            <a:pPr marL="342900" indent="-342900">
-              <a:spcAft>
-                <a:spcPts val="1200"/>
-              </a:spcAft>
-              <a:buSzPct val="100000"/>
-              <a:buChar char="•"/>
-            </a:pPr>
-            <a:r>
-              <a:rPr lang="en-US" sz="1700" dirty="0">
-                <a:solidFill>
-                  <a:srgbClr val="BDBBB0"/>
-                </a:solidFill>
-                <a:latin typeface="Calibri" pitchFamily="34" charset="0"/>
-                <a:ea typeface="Calibri" pitchFamily="34" charset="-122"/>
-                <a:cs typeface="Calibri" pitchFamily="34" charset="-120"/>
-              </a:rPr>
-              <a:t>Photos searchable by what they show</a:t>
-            </a:r>
-            <a:endParaRPr lang="en-US" sz="1700" dirty="0"/>
-          </a:p>
-          <a:p>
-            <a:pPr marL="342900" indent="-342900">
-              <a:spcAft>
-                <a:spcPts val="1200"/>
-              </a:spcAft>
-              <a:buSzPct val="100000"/>
-              <a:buChar char="•"/>
-            </a:pPr>
-            <a:r>
-              <a:rPr lang="en-US" sz="1700" dirty="0">
-                <a:solidFill>
-                  <a:srgbClr val="BDBBB0"/>
-                </a:solidFill>
-                <a:latin typeface="Calibri" pitchFamily="34" charset="0"/>
-                <a:ea typeface="Calibri" pitchFamily="34" charset="-122"/>
-                <a:cs typeface="Calibri" pitchFamily="34" charset="-120"/>
-              </a:rPr>
-              <a:t>Encrypted backup, shift report, one-click conflict</a:t>
-            </a:r>
-            <a:endParaRPr lang="en-US" sz="1700" dirty="0"/>
-          </a:p>
-          <a:p>
-            <a:pPr marL="342900" indent="-342900">
-              <a:spcAft>
-                <a:spcPts val="1200"/>
-              </a:spcAft>
-              <a:buSzPct val="100000"/>
-              <a:buChar char="•"/>
-            </a:pPr>
-            <a:r>
-              <a:rPr lang="en-US" sz="1700" dirty="0">
-                <a:solidFill>
-                  <a:srgbClr val="BDBBB0"/>
-                </a:solidFill>
-                <a:latin typeface="Calibri" pitchFamily="34" charset="0"/>
-                <a:ea typeface="Calibri" pitchFamily="34" charset="-122"/>
-                <a:cs typeface="Calibri" pitchFamily="34" charset="-120"/>
-              </a:rPr>
-              <a:t>Installable on a phone; Hindi optional</a:t>
+              <a:t>Hands-free dictation in any language, on the device</a:t>
             </a:r>
             <a:endParaRPr lang="en-US" sz="1700" dirty="0"/>
           </a:p>

</xml_diff>

<commit_message>
Multilingual name masking, audit export, more address forms
FIELDMIND_NAME_MODEL=multilingual adds a BERT NER model that reads names in
Devanagari, Tamil, Spanish and other scripts; the English model keeps running
beside it so English recall is unchanged. The address detector now also
catches numbered streets, numbered sectors with a place name, landmarks and
postal codes (a postal code is no longer taken for a PIN credential). The
activity log exports as JSON lines from the Sync page, every line stamped
with device and site. Storage figures are labelled as reserved up front.
Twelve new tests, 123 in all; docs and deck updated.
</commit_message>
<xml_diff>
--- a/docs/FieldMind-Compilers.pptx
+++ b/docs/FieldMind-Compilers.pptx
@@ -2242,7 +2242,7 @@
                 </a:solidFill>
                 <a:latin typeface="Calibri"/>
               </a:rPr>
-              <a:t>MIT. 111 tests on every push against a real Qdrant Server and a real browser. docker compose --profile demo up runs it on any laptop.</a:t>
+              <a:t>MIT. 123 tests on every push against a real Qdrant Server and a real browser. docker compose --profile demo up runs it on any laptop.</a:t>
             </a:r>
           </a:p>
         </p:txBody>
@@ -8207,7 +8207,7 @@
                 <a:ea typeface="Arial" pitchFamily="34" charset="-122"/>
                 <a:cs typeface="Arial" pitchFamily="34" charset="-120"/>
               </a:rPr>
-              <a:t>111</a:t>
+              <a:t>123</a:t>
             </a:r>
             <a:endParaRPr lang="en-US" sz="5400" dirty="0"/>
           </a:p>

</xml_diff>

<commit_message>
Approvals: trainee notes wait for a supervisor, safety hazards never do
Every device has a role (FIELDMIND_ROLE): trainee, technician (default) or
supervisor. A trainee's shared notes travel marked as awaiting approval and
only supervisor devices pull them until one approves; technicians and
supervisors share at once. Approve and reject are queued like any change, so
they work offline, and reach the cloud as compare-and-swap patches: a note
the author rewrote after it was read goes back to the queue instead of being
released. A rejection is a tombstone carrying the reason, and the note comes
back to its author as private; editing it resubmits. Safety hazards reach
everyone immediately and are reviewed afterwards. Ten approvals in a row make
a device trusted; one rejection resets that. Peers apply the same rule.

Dashboard: an Approvals pane on the Sync page, review badges on notes, the
role in the device status and the note drawer. Nine new tests, 132 in all.
</commit_message>
<xml_diff>
--- a/docs/FieldMind-Compilers.pptx
+++ b/docs/FieldMind-Compilers.pptx
@@ -2242,7 +2242,7 @@
                 </a:solidFill>
                 <a:latin typeface="Calibri"/>
               </a:rPr>
-              <a:t>MIT. 123 tests on every push against a real Qdrant Server and a real browser. docker compose --profile demo up runs it on any laptop.</a:t>
+              <a:t>MIT. 132 tests on every push against a real Qdrant Server and a real browser. docker compose --profile demo up runs it on any laptop.</a:t>
             </a:r>
           </a:p>
         </p:txBody>
@@ -8207,7 +8207,7 @@
                 <a:ea typeface="Arial" pitchFamily="34" charset="-122"/>
                 <a:cs typeface="Arial" pitchFamily="34" charset="-120"/>
               </a:rPr>
-              <a:t>123</a:t>
+              <a:t>132</a:t>
             </a:r>
             <a:endParaRPr lang="en-US" sz="5400" dirty="0"/>
           </a:p>

</xml_diff>

<commit_message>
Faces hidden in shared photos, note revisions, change-log pull sync
Photos: a 1.3 MB face detector (UltraFace RFB-320, ONNX) runs on the device
in about 15 ms. The copy that leaves has every face pixelated and the vector
the fleet searches by is computed from that copy; the technician keeps the
whole photo. FIELDMIND_FACES=0 turns it off.

Revisions: every version of a note this device held is kept in the journal,
sealed like the activity log, with the device, author and reason. The note
drawer lists them with a diff against the current text and a Restore button;
a restore is an ordinary new change and syncs like one.

Pull sync: each cycle asks the cloud only for memories updated since the last
one (five-minute overlap for clock drift) instead of listing the whole site.
Every FIELDMIND_FULL_PULL_EVERY cycles (30), and whenever the collection had to
be created, the whole site is listed, which is when deletions and a rebuilt
cloud are noticed. Nine new tests, 141 in all.
</commit_message>
<xml_diff>
--- a/docs/FieldMind-Compilers.pptx
+++ b/docs/FieldMind-Compilers.pptx
@@ -2242,7 +2242,7 @@
                 </a:solidFill>
                 <a:latin typeface="Calibri"/>
               </a:rPr>
-              <a:t>MIT. 132 tests on every push against a real Qdrant Server and a real browser. docker compose --profile demo up runs it on any laptop.</a:t>
+              <a:t>MIT. 141 tests on every push against a real Qdrant Server and a real browser. docker compose --profile demo up runs it on any laptop.</a:t>
             </a:r>
           </a:p>
         </p:txBody>
@@ -8207,7 +8207,7 @@
                 <a:ea typeface="Arial" pitchFamily="34" charset="-122"/>
                 <a:cs typeface="Arial" pitchFamily="34" charset="-120"/>
               </a:rPr>
-              <a:t>132</a:t>
+              <a:t>141</a:t>
             </a:r>
             <a:endParaRPr lang="en-US" sz="5400" dirty="0"/>
           </a:p>

</xml_diff>

<commit_message>
Announcements: a supervisor tells the site something for a set time
A supervisor writes an announcement with a duration (an hour to two weeks).
It is a memory of kind announcement with an expiry, shared, at urgent
priority, so it leaves first and never waits for approval; names in it are
kept because the supervisor chose to broadcast them, a credential still
blocks it. Every device on the site shows it at the top of Work with the
time left. Each device drops it on its own when it expires, so an offline
device loses it too, and the author's device deletes it in the cloud so it
cannot be pulled again. Take down early with one click. Four new tests,
145 in all.
</commit_message>
<xml_diff>
--- a/docs/FieldMind-Compilers.pptx
+++ b/docs/FieldMind-Compilers.pptx
@@ -2242,7 +2242,7 @@
                 </a:solidFill>
                 <a:latin typeface="Calibri"/>
               </a:rPr>
-              <a:t>MIT. 141 tests on every push against a real Qdrant Server and a real browser. docker compose --profile demo up runs it on any laptop.</a:t>
+              <a:t>MIT. 145 tests on every push against a real Qdrant Server and a real browser. docker compose --profile demo up runs it on any laptop.</a:t>
             </a:r>
           </a:p>
         </p:txBody>
@@ -8207,7 +8207,7 @@
                 <a:ea typeface="Arial" pitchFamily="34" charset="-122"/>
                 <a:cs typeface="Arial" pitchFamily="34" charset="-120"/>
               </a:rPr>
-              <a:t>141</a:t>
+              <a:t>145</a:t>
             </a:r>
             <a:endParaRPr lang="en-US" sz="5400" dirty="0"/>
           </a:p>

</xml_diff>